<commit_message>
Add Module 14b (SQLite/JDBC) and JavaFX Module 18; move Swing to Appendix A
- New optional Module 14b: Databases with SQLite & JDBC, with the driver
  jar in lib/, 10 examples, 2 checked exercises and 3 project tracks
- Module 18 is now GUIs with JavaFX: Maven projects (JavaFX 21), 15
  examples, exercises with JUnit tests, and 3 project starters
- The Swing module moves to the optional Appendix A
- Update the roadmap, cross-references, Capstone 2 stretch goals,
  .gitignore, slides and the Student Manual

Co-Authored-By: Claude Opus 5.5 <noreply@anthropic.com>
</commit_message>
<xml_diff>
--- a/Slides/Module-14-Files-and-Data.pptx
+++ b/Slides/Module-14-Files-and-Data.pptx
@@ -114,7 +114,7 @@
   <p:extLst>
     <p:ext uri="{521415D9-36F7-43E2-AB2F-B90AF26B5E84}">
       <p14:sectionLst xmlns:p14="http://schemas.microsoft.com/office/powerpoint/2010/main">
-        <p14:section name="Module 14" id="{cab94b21-30a2-bc0c-3bc3-b13af246fb04}">
+        <p14:section name="Module 14" id="{561f56b5-1069-f93e-c4d3-9af03359b4bd}">
           <p14:sldIdLst>
             <p14:sldId id="256"/>
             <p14:sldId id="257"/>
@@ -10998,7 +10998,7 @@
                   <a:srgbClr val="F89820"/>
                 </a:solidFill>
               </a:rPr>
-              <a:t>Next: Module 15, Generics, Collections &amp; Lambdas</a:t>
+              <a:t>Next: Module 15 (or the optional 14b, Databases)</a:t>
             </a:r>
             <a:endParaRPr lang="en-US" sz="1250" dirty="0"/>
           </a:p>

</xml_diff>